<commit_message>
Add the logo lockup to the deck and tighten the copy
The cover and closing slide now carry the wordmark lockup built from
candidate 01's symbol instead of plain type, and the vector sources ship
alongside it.

Copy went through a pass for length: the opening and closing paragraphs
each lose a line, the material-and-person page ends on one sentence
instead of two, and the character descriptions, form rules and visual
traits drop words that were not carrying meaning. Nothing was added.

Co-Authored-By: Claude Opus 5 <noreply@anthropic.com>
Claude-Session: https://claude.ai/code/session_01AuY3mdfZZHmzHZEy6dujdY
</commit_message>
<xml_diff>
--- a/Wuzu_Tokki_IP_소개서_20260922.pptx
+++ b/Wuzu_Tokki_IP_소개서_20260922.pptx
@@ -1700,54 +1700,39 @@
           </a:prstGeom>
         </p:spPr>
       </p:pic>
-      <p:sp>
-        <p:nvSpPr>
-          <p:cNvPr id="3" name="Text 0"/>
-          <p:cNvSpPr/>
-          <p:nvPr/>
-        </p:nvSpPr>
-        <p:spPr>
-          <a:xfrm>
-            <a:off x="822960" y="2331720"/>
-            <a:ext cx="2651760" cy="420624"/>
-          </a:xfrm>
-          <a:prstGeom prst="rect">
-            <a:avLst/>
-          </a:prstGeom>
-          <a:noFill/>
-          <a:ln/>
-        </p:spPr>
-        <p:txBody>
-          <a:bodyPr wrap="square" rtlCol="0" anchor="ctr"/>
-          <a:lstStyle/>
-          <a:p>
-            <a:pPr indent="0" marL="0">
-              <a:buNone/>
-            </a:pPr>
-            <a:r>
-              <a:rPr lang="en-US" sz="2400" spc="40" kern="0" dirty="0">
-                <a:solidFill>
-                  <a:srgbClr val="1A1A1A"/>
-                </a:solidFill>
-                <a:latin typeface="Noto Sans KR" pitchFamily="34" charset="0"/>
-                <a:ea typeface="Noto Sans KR" pitchFamily="34" charset="-122"/>
-                <a:cs typeface="Noto Sans KR" pitchFamily="34" charset="-120"/>
-              </a:rPr>
-              <a:t>wuzu tokki</a:t>
-            </a:r>
-            <a:endParaRPr lang="en-US" sz="2400" dirty="0"/>
-          </a:p>
-        </p:txBody>
-      </p:sp>
-      <p:sp>
-        <p:nvSpPr>
-          <p:cNvPr id="4" name="Text 1"/>
-          <p:cNvSpPr/>
-          <p:nvPr/>
-        </p:nvSpPr>
-        <p:spPr>
-          <a:xfrm>
-            <a:off x="822960" y="2798064"/>
+      <p:pic>
+        <p:nvPicPr>
+          <p:cNvPr id="3" name="Image 1" descr="/home/user/hoho/assets/logo-lockup.png">    </p:cNvPr>
+          <p:cNvPicPr>
+            <a:picLocks noChangeAspect="1"/>
+          </p:cNvPicPr>
+          <p:nvPr/>
+        </p:nvPicPr>
+        <p:blipFill>
+          <a:blip r:embed="rId2"/>
+          <a:stretch>
+            <a:fillRect/>
+          </a:stretch>
+        </p:blipFill>
+        <p:spPr>
+          <a:xfrm>
+            <a:off x="717356" y="2134627"/>
+            <a:ext cx="2753239" cy="769760"/>
+          </a:xfrm>
+          <a:prstGeom prst="rect">
+            <a:avLst/>
+          </a:prstGeom>
+        </p:spPr>
+      </p:pic>
+      <p:sp>
+        <p:nvSpPr>
+          <p:cNvPr id="4" name="Text 0"/>
+          <p:cNvSpPr/>
+          <p:nvPr/>
+        </p:nvSpPr>
+        <p:spPr>
+          <a:xfrm>
+            <a:off x="822960" y="2926749"/>
             <a:ext cx="2651760" cy="256032"/>
           </a:xfrm>
           <a:prstGeom prst="rect">
@@ -1780,13 +1765,13 @@
       </p:sp>
       <p:sp>
         <p:nvSpPr>
-          <p:cNvPr id="5" name="Shape 2"/>
-          <p:cNvSpPr/>
-          <p:nvPr/>
-        </p:nvSpPr>
-        <p:spPr>
-          <a:xfrm>
-            <a:off x="822960" y="3310128"/>
+          <p:cNvPr id="5" name="Shape 1"/>
+          <p:cNvSpPr/>
+          <p:nvPr/>
+        </p:nvSpPr>
+        <p:spPr>
+          <a:xfrm>
+            <a:off x="822960" y="3401568"/>
             <a:ext cx="457200" cy="5486"/>
           </a:xfrm>
           <a:prstGeom prst="rect">
@@ -1805,13 +1790,13 @@
       </p:sp>
       <p:sp>
         <p:nvSpPr>
-          <p:cNvPr id="6" name="Text 3"/>
-          <p:cNvSpPr/>
-          <p:nvPr/>
-        </p:nvSpPr>
-        <p:spPr>
-          <a:xfrm>
-            <a:off x="822960" y="3511296"/>
+          <p:cNvPr id="6" name="Text 2"/>
+          <p:cNvSpPr/>
+          <p:nvPr/>
+        </p:nvSpPr>
+        <p:spPr>
+          <a:xfrm>
+            <a:off x="822960" y="3602736"/>
             <a:ext cx="2651760" cy="548640"/>
           </a:xfrm>
           <a:prstGeom prst="rect">
@@ -1862,45 +1847,6 @@
               <a:t>이루어진 토끼들</a:t>
             </a:r>
             <a:endParaRPr lang="en-US" sz="1000" dirty="0"/>
-          </a:p>
-        </p:txBody>
-      </p:sp>
-      <p:sp>
-        <p:nvSpPr>
-          <p:cNvPr id="7" name="Text 4"/>
-          <p:cNvSpPr/>
-          <p:nvPr/>
-        </p:nvSpPr>
-        <p:spPr>
-          <a:xfrm>
-            <a:off x="822960" y="6309360"/>
-            <a:ext cx="2651760" cy="219456"/>
-          </a:xfrm>
-          <a:prstGeom prst="rect">
-            <a:avLst/>
-          </a:prstGeom>
-          <a:noFill/>
-          <a:ln/>
-        </p:spPr>
-        <p:txBody>
-          <a:bodyPr wrap="square" rtlCol="0" anchor="ctr"/>
-          <a:lstStyle/>
-          <a:p>
-            <a:pPr indent="0" marL="0">
-              <a:buNone/>
-            </a:pPr>
-            <a:r>
-              <a:rPr lang="en-US" sz="750" spc="260" kern="0" dirty="0">
-                <a:solidFill>
-                  <a:srgbClr val="9A9A9A"/>
-                </a:solidFill>
-                <a:latin typeface="Noto Sans KR" pitchFamily="34" charset="0"/>
-                <a:ea typeface="Noto Sans KR" pitchFamily="34" charset="-122"/>
-                <a:cs typeface="Noto Sans KR" pitchFamily="34" charset="-120"/>
-              </a:rPr>
-              <a:t>character ip</a:t>
-            </a:r>
-            <a:endParaRPr lang="en-US" sz="750" dirty="0"/>
           </a:p>
         </p:txBody>
       </p:sp>
@@ -2060,7 +2006,7 @@
                 <a:ea typeface="Noto Sans KR" pitchFamily="34" charset="-122"/>
                 <a:cs typeface="Noto Sans KR" pitchFamily="34" charset="-120"/>
               </a:rPr>
-              <a:t>서로 다른 물질로 이루어진</a:t>
+              <a:t>서로 다른 물질로 이루어진 우주토끼들이</a:t>
             </a:r>
             <a:endParaRPr lang="en-US" sz="950" dirty="0"/>
           </a:p>
@@ -2080,10 +2026,32 @@
                 <a:ea typeface="Noto Sans KR" pitchFamily="34" charset="-122"/>
                 <a:cs typeface="Noto Sans KR" pitchFamily="34" charset="-120"/>
               </a:rPr>
-              <a:t>우주토끼들은 우리에게</a:t>
+              <a:t>하나의 질문을 건넵니다.</a:t>
             </a:r>
             <a:endParaRPr lang="en-US" sz="950" dirty="0"/>
           </a:p>
+        </p:txBody>
+      </p:sp>
+      <p:sp>
+        <p:nvSpPr>
+          <p:cNvPr id="6" name="Text 3"/>
+          <p:cNvSpPr/>
+          <p:nvPr/>
+        </p:nvSpPr>
+        <p:spPr>
+          <a:xfrm>
+            <a:off x="8686800" y="3200400"/>
+            <a:ext cx="2697480" cy="1097280"/>
+          </a:xfrm>
+          <a:prstGeom prst="rect">
+            <a:avLst/>
+          </a:prstGeom>
+          <a:noFill/>
+          <a:ln/>
+        </p:spPr>
+        <p:txBody>
+          <a:bodyPr wrap="square" rtlCol="0" anchor="ctr"/>
+          <a:lstStyle/>
           <a:p>
             <a:pPr indent="0" marL="0">
               <a:lnSpc>
@@ -2094,38 +2062,16 @@
             <a:r>
               <a:rPr lang="en-US" sz="950" dirty="0">
                 <a:solidFill>
-                  <a:srgbClr val="5A5A5A"/>
-                </a:solidFill>
-                <a:latin typeface="Noto Sans KR" pitchFamily="34" charset="0"/>
-                <a:ea typeface="Noto Sans KR" pitchFamily="34" charset="-122"/>
-                <a:cs typeface="Noto Sans KR" pitchFamily="34" charset="-120"/>
-              </a:rPr>
-              <a:t>하나의 질문을 건넵니다.</a:t>
+                  <a:srgbClr val="1A1A1A"/>
+                </a:solidFill>
+                <a:latin typeface="Noto Sans KR" pitchFamily="34" charset="0"/>
+                <a:ea typeface="Noto Sans KR" pitchFamily="34" charset="-122"/>
+                <a:cs typeface="Noto Sans KR" pitchFamily="34" charset="-120"/>
+              </a:rPr>
+              <a:t>나는 어떤 성질을 지녔는지,</a:t>
             </a:r>
             <a:endParaRPr lang="en-US" sz="950" dirty="0"/>
           </a:p>
-        </p:txBody>
-      </p:sp>
-      <p:sp>
-        <p:nvSpPr>
-          <p:cNvPr id="6" name="Text 3"/>
-          <p:cNvSpPr/>
-          <p:nvPr/>
-        </p:nvSpPr>
-        <p:spPr>
-          <a:xfrm>
-            <a:off x="8686800" y="3364992"/>
-            <a:ext cx="2697480" cy="1097280"/>
-          </a:xfrm>
-          <a:prstGeom prst="rect">
-            <a:avLst/>
-          </a:prstGeom>
-          <a:noFill/>
-          <a:ln/>
-        </p:spPr>
-        <p:txBody>
-          <a:bodyPr wrap="square" rtlCol="0" anchor="ctr"/>
-          <a:lstStyle/>
           <a:p>
             <a:pPr indent="0" marL="0">
               <a:lnSpc>
@@ -2142,7 +2088,7 @@
                 <a:ea typeface="Noto Sans KR" pitchFamily="34" charset="-122"/>
                 <a:cs typeface="Noto Sans KR" pitchFamily="34" charset="-120"/>
               </a:rPr>
-              <a:t>나는 어떤 성질을 가지고 있는지,</a:t>
+              <a:t>어떤 흔적을 품고 있는지,</a:t>
             </a:r>
             <a:endParaRPr lang="en-US" sz="950" dirty="0"/>
           </a:p>
@@ -2162,47 +2108,7 @@
                 <a:ea typeface="Noto Sans KR" pitchFamily="34" charset="-122"/>
                 <a:cs typeface="Noto Sans KR" pitchFamily="34" charset="-120"/>
               </a:rPr>
-              <a:t>어떤 흔적을 품고 있는지,</a:t>
-            </a:r>
-            <a:endParaRPr lang="en-US" sz="950" dirty="0"/>
-          </a:p>
-          <a:p>
-            <a:pPr indent="0" marL="0">
-              <a:lnSpc>
-                <a:spcPts val="1700"/>
-              </a:lnSpc>
-              <a:buNone/>
-            </a:pPr>
-            <a:r>
-              <a:rPr lang="en-US" sz="950" dirty="0">
-                <a:solidFill>
-                  <a:srgbClr val="1A1A1A"/>
-                </a:solidFill>
-                <a:latin typeface="Noto Sans KR" pitchFamily="34" charset="0"/>
-                <a:ea typeface="Noto Sans KR" pitchFamily="34" charset="-122"/>
-                <a:cs typeface="Noto Sans KR" pitchFamily="34" charset="-120"/>
-              </a:rPr>
-              <a:t>그리고 어떤 모습으로</a:t>
-            </a:r>
-            <a:endParaRPr lang="en-US" sz="950" dirty="0"/>
-          </a:p>
-          <a:p>
-            <a:pPr indent="0" marL="0">
-              <a:lnSpc>
-                <a:spcPts val="1700"/>
-              </a:lnSpc>
-              <a:buNone/>
-            </a:pPr>
-            <a:r>
-              <a:rPr lang="en-US" sz="950" dirty="0">
-                <a:solidFill>
-                  <a:srgbClr val="1A1A1A"/>
-                </a:solidFill>
-                <a:latin typeface="Noto Sans KR" pitchFamily="34" charset="0"/>
-                <a:ea typeface="Noto Sans KR" pitchFamily="34" charset="-122"/>
-                <a:cs typeface="Noto Sans KR" pitchFamily="34" charset="-120"/>
-              </a:rPr>
-              <a:t>변해가고 있는지.</a:t>
+              <a:t>어떤 모습으로 변해가는지.</a:t>
             </a:r>
             <a:endParaRPr lang="en-US" sz="950" dirty="0"/>
           </a:p>
@@ -2272,45 +2178,30 @@
           </a:p>
         </p:txBody>
       </p:sp>
-      <p:sp>
-        <p:nvSpPr>
-          <p:cNvPr id="9" name="Text 6"/>
-          <p:cNvSpPr/>
-          <p:nvPr/>
-        </p:nvSpPr>
-        <p:spPr>
-          <a:xfrm>
-            <a:off x="8686800" y="5779008"/>
-            <a:ext cx="2697480" cy="219456"/>
-          </a:xfrm>
-          <a:prstGeom prst="rect">
-            <a:avLst/>
-          </a:prstGeom>
-          <a:noFill/>
-          <a:ln/>
-        </p:spPr>
-        <p:txBody>
-          <a:bodyPr wrap="square" rtlCol="0" anchor="ctr"/>
-          <a:lstStyle/>
-          <a:p>
-            <a:pPr indent="0" marL="0">
-              <a:buNone/>
-            </a:pPr>
-            <a:r>
-              <a:rPr lang="en-US" sz="750" spc="160" kern="0" dirty="0">
-                <a:solidFill>
-                  <a:srgbClr val="9A9A9A"/>
-                </a:solidFill>
-                <a:latin typeface="Noto Sans KR" pitchFamily="34" charset="0"/>
-                <a:ea typeface="Noto Sans KR" pitchFamily="34" charset="-122"/>
-                <a:cs typeface="Noto Sans KR" pitchFamily="34" charset="-120"/>
-              </a:rPr>
-              <a:t>wuzu tokki · 우주토끼</a:t>
-            </a:r>
-            <a:endParaRPr lang="en-US" sz="750" dirty="0"/>
-          </a:p>
-        </p:txBody>
-      </p:sp>
+      <p:pic>
+        <p:nvPicPr>
+          <p:cNvPr id="9" name="Image 1" descr="/home/user/hoho/assets/logo-lockup.png">    </p:cNvPr>
+          <p:cNvPicPr>
+            <a:picLocks noChangeAspect="1"/>
+          </p:cNvPicPr>
+          <p:nvPr/>
+        </p:nvPicPr>
+        <p:blipFill>
+          <a:blip r:embed="rId2"/>
+          <a:stretch>
+            <a:fillRect/>
+          </a:stretch>
+        </p:blipFill>
+        <p:spPr>
+          <a:xfrm>
+            <a:off x="8631719" y="5650749"/>
+            <a:ext cx="1436042" cy="401493"/>
+          </a:xfrm>
+          <a:prstGeom prst="rect">
+            <a:avLst/>
+          </a:prstGeom>
+        </p:spPr>
+      </p:pic>
     </p:spTree>
   </p:cSld>
   <p:clrMapOvr>
@@ -2447,7 +2338,7 @@
         <p:spPr>
           <a:xfrm>
             <a:off x="822960" y="1572768"/>
-            <a:ext cx="7863840" cy="1066800"/>
+            <a:ext cx="7863840" cy="800100"/>
           </a:xfrm>
           <a:prstGeom prst="rect">
             <a:avLst/>
@@ -2514,27 +2405,7 @@
                 <a:ea typeface="Noto Sans KR" pitchFamily="34" charset="-122"/>
                 <a:cs typeface="Noto Sans KR" pitchFamily="34" charset="-120"/>
               </a:rPr>
-              <a:t>같은 토끼의 형태를 가지고 있지만</a:t>
-            </a:r>
-            <a:endParaRPr lang="en-US" sz="1050" dirty="0"/>
-          </a:p>
-          <a:p>
-            <a:pPr indent="0" marL="0">
-              <a:lnSpc>
-                <a:spcPts val="2100"/>
-              </a:lnSpc>
-              <a:buNone/>
-            </a:pPr>
-            <a:r>
-              <a:rPr lang="en-US" sz="1050" dirty="0">
-                <a:solidFill>
-                  <a:srgbClr val="5A5A5A"/>
-                </a:solidFill>
-                <a:latin typeface="Noto Sans KR" pitchFamily="34" charset="0"/>
-                <a:ea typeface="Noto Sans KR" pitchFamily="34" charset="-122"/>
-                <a:cs typeface="Noto Sans KR" pitchFamily="34" charset="-120"/>
-              </a:rPr>
-              <a:t>각자가 가진 촉감과 무게, 흔적과 변화는 모두 다릅니다.</a:t>
+              <a:t>형태는 같지만, 촉감과 무게와 흔적은 저마다 다릅니다.</a:t>
             </a:r>
             <a:endParaRPr lang="en-US" sz="1050" dirty="0"/>
           </a:p>
@@ -2825,7 +2696,7 @@
                 <a:ea typeface="Noto Sans KR" pitchFamily="34" charset="-122"/>
                 <a:cs typeface="Noto Sans KR" pitchFamily="34" charset="-120"/>
               </a:rPr>
-              <a:t>어떤 물질은 오랜 시간 흔적을 품습니다.</a:t>
+              <a:t>어떤 물질은 오래 흔적을 품습니다.</a:t>
             </a:r>
             <a:endParaRPr lang="en-US" sz="1150" dirty="0"/>
           </a:p>
@@ -2845,7 +2716,7 @@
                 <a:ea typeface="Noto Sans KR" pitchFamily="34" charset="-122"/>
                 <a:cs typeface="Noto Sans KR" pitchFamily="34" charset="-120"/>
               </a:rPr>
-              <a:t>어떤 것은 흩어졌다가 다시 모이고,</a:t>
+              <a:t>어떤 것은 흩어졌다 다시 모이고,</a:t>
             </a:r>
             <a:endParaRPr lang="en-US" sz="1150" dirty="0"/>
           </a:p>
@@ -2865,7 +2736,7 @@
                 <a:ea typeface="Noto Sans KR" pitchFamily="34" charset="-122"/>
                 <a:cs typeface="Noto Sans KR" pitchFamily="34" charset="-120"/>
               </a:rPr>
-              <a:t>어떤 것은 단단하지만 작은 균열을 가지고 있습니다.</a:t>
+              <a:t>어떤 것은 단단한 채로 작은 균열을 지닙니다.</a:t>
             </a:r>
             <a:endParaRPr lang="en-US" sz="1150" dirty="0"/>
           </a:p>
@@ -2880,7 +2751,7 @@
         <p:spPr>
           <a:xfrm>
             <a:off x="822960" y="3611880"/>
-            <a:ext cx="5852160" cy="508000"/>
+            <a:ext cx="6766560" cy="254000"/>
           </a:xfrm>
           <a:prstGeom prst="rect">
             <a:avLst/>
@@ -2907,27 +2778,7 @@
                 <a:ea typeface="Noto Sans KR" pitchFamily="34" charset="-122"/>
                 <a:cs typeface="Noto Sans KR" pitchFamily="34" charset="-120"/>
               </a:rPr>
-              <a:t>우주토끼는 물질의 성질을 통해</a:t>
-            </a:r>
-            <a:endParaRPr lang="en-US" sz="1000" dirty="0"/>
-          </a:p>
-          <a:p>
-            <a:pPr indent="0" marL="0">
-              <a:lnSpc>
-                <a:spcPts val="2000"/>
-              </a:lnSpc>
-              <a:buNone/>
-            </a:pPr>
-            <a:r>
-              <a:rPr lang="en-US" sz="1000" dirty="0">
-                <a:solidFill>
-                  <a:srgbClr val="5A5A5A"/>
-                </a:solidFill>
-                <a:latin typeface="Noto Sans KR" pitchFamily="34" charset="0"/>
-                <a:ea typeface="Noto Sans KR" pitchFamily="34" charset="-122"/>
-                <a:cs typeface="Noto Sans KR" pitchFamily="34" charset="-120"/>
-              </a:rPr>
-              <a:t>우리가 가진 서로 다른 모습을 바라봅니다.</a:t>
+              <a:t>우주토끼는 그 성질로 우리의 서로 다른 모습을 바라봅니다.</a:t>
             </a:r>
             <a:endParaRPr lang="en-US" sz="1000" dirty="0"/>
           </a:p>
@@ -3348,7 +3199,7 @@
                 <a:ea typeface="Noto Sans KR" pitchFamily="34" charset="-122"/>
                 <a:cs typeface="Noto Sans KR" pitchFamily="34" charset="-120"/>
               </a:rPr>
-              <a:t>안정적으로 바닥에 닿는 배와 발</a:t>
+              <a:t>바닥에 안정적으로 닿는 배와 발</a:t>
             </a:r>
             <a:endParaRPr lang="en-US" sz="900" dirty="0"/>
           </a:p>
@@ -3476,7 +3327,7 @@
                 <a:ea typeface="Noto Sans KR" pitchFamily="34" charset="-122"/>
                 <a:cs typeface="Noto Sans KR" pitchFamily="34" charset="-120"/>
               </a:rPr>
-              <a:t>반드시 존재하는 귀와 꼬리</a:t>
+              <a:t>언제나 있는 귀와 꼬리</a:t>
             </a:r>
             <a:endParaRPr lang="en-US" sz="900" dirty="0"/>
           </a:p>
@@ -3668,7 +3519,7 @@
                 <a:ea typeface="Noto Sans KR" pitchFamily="34" charset="-122"/>
                 <a:cs typeface="Noto Sans KR" pitchFamily="34" charset="-120"/>
               </a:rPr>
-              <a:t>장식보다 재료 자체의 특징을 우선</a:t>
+              <a:t>장식보다 재료의 특징을 우선</a:t>
             </a:r>
             <a:endParaRPr lang="en-US" sz="900" dirty="0"/>
           </a:p>
@@ -3992,7 +3843,7 @@
                 <a:ea typeface="Noto Sans KR" pitchFamily="34" charset="-122"/>
                 <a:cs typeface="Noto Sans KR" pitchFamily="34" charset="-120"/>
               </a:rPr>
-              <a:t>길게 자란 털이 몸의 윤곽을 부드럽게 덮습니다.</a:t>
+              <a:t>길게 자란 털이 몸의 윤곽을 덮습니다.</a:t>
             </a:r>
             <a:endParaRPr lang="en-US" sz="850" dirty="0"/>
           </a:p>
@@ -4034,7 +3885,7 @@
                 <a:ea typeface="Noto Sans KR" pitchFamily="34" charset="-122"/>
                 <a:cs typeface="Noto Sans KR" pitchFamily="34" charset="-120"/>
               </a:rPr>
-              <a:t>나는 서로 다른 사람들 사이를 잇는 자리에 서 있을까요?</a:t>
+              <a:t>나는 사람들 사이를 잇는 자리에 서 있을까요?</a:t>
             </a:r>
             <a:endParaRPr lang="en-US" sz="850" dirty="0"/>
           </a:p>
@@ -4129,7 +3980,7 @@
                 <a:ea typeface="Noto Sans KR" pitchFamily="34" charset="-122"/>
                 <a:cs typeface="Noto Sans KR" pitchFamily="34" charset="-120"/>
               </a:rPr>
-              <a:t>회백색 표면 위에 크고 작은 분화구가 남아 있습니다.</a:t>
+              <a:t>회백색 표면에 크고 작은 분화구가 남아 있습니다.</a:t>
             </a:r>
             <a:endParaRPr lang="en-US" sz="850" dirty="0"/>
           </a:p>
@@ -4171,7 +4022,7 @@
                 <a:ea typeface="Noto Sans KR" pitchFamily="34" charset="-122"/>
                 <a:cs typeface="Noto Sans KR" pitchFamily="34" charset="-120"/>
               </a:rPr>
-              <a:t>나는 지나온 시간의 흔적을 오래 간직하는 편일까요?</a:t>
+              <a:t>나는 지나온 흔적을 오래 간직하는 편일까요?</a:t>
             </a:r>
             <a:endParaRPr lang="en-US" sz="850" dirty="0"/>
           </a:p>
@@ -4266,7 +4117,7 @@
                 <a:ea typeface="Noto Sans KR" pitchFamily="34" charset="-122"/>
                 <a:cs typeface="Noto Sans KR" pitchFamily="34" charset="-120"/>
               </a:rPr>
-              <a:t>희고 푸른 기가 도는 몸이 덩어리처럼 뭉쳐 있습니다.</a:t>
+              <a:t>희고 푸른 기가 도는 몸이 덩어리로 뭉쳐 있습니다.</a:t>
             </a:r>
             <a:endParaRPr lang="en-US" sz="850" dirty="0"/>
           </a:p>
@@ -4445,7 +4296,7 @@
                 <a:ea typeface="Noto Sans KR" pitchFamily="34" charset="-122"/>
                 <a:cs typeface="Noto Sans KR" pitchFamily="34" charset="-120"/>
               </a:rPr>
-              <a:t>나는 눌린 자리에서 새로운 모양이 되는 편일까요?</a:t>
+              <a:t>나는 눌린 자리에서 새 모양이 되는 편일까요?</a:t>
             </a:r>
             <a:endParaRPr lang="en-US" sz="850" dirty="0"/>
           </a:p>
@@ -4540,7 +4391,7 @@
                 <a:ea typeface="Noto Sans KR" pitchFamily="34" charset="-122"/>
                 <a:cs typeface="Noto Sans KR" pitchFamily="34" charset="-120"/>
               </a:rPr>
-              <a:t>단단하게 굳은 표면 안쪽으로 가는 결이 지나갑니다.</a:t>
+              <a:t>단단히 굳은 표면 안쪽으로 가는 결이 지나갑니다.</a:t>
             </a:r>
             <a:endParaRPr lang="en-US" sz="850" dirty="0"/>
           </a:p>
@@ -4582,7 +4433,7 @@
                 <a:ea typeface="Noto Sans KR" pitchFamily="34" charset="-122"/>
                 <a:cs typeface="Noto Sans KR" pitchFamily="34" charset="-120"/>
               </a:rPr>
-              <a:t>나는 단단해 보이는 안쪽에 어떤 결을 품고 있을까요?</a:t>
+              <a:t>나는 단단한 겉 안쪽에 어떤 결을 품고 있을까요?</a:t>
             </a:r>
             <a:endParaRPr lang="en-US" sz="850" dirty="0"/>
           </a:p>
@@ -6885,7 +6736,7 @@
                 <a:ea typeface="Noto Sans KR" pitchFamily="34" charset="-122"/>
                 <a:cs typeface="Noto Sans KR" pitchFamily="34" charset="-120"/>
               </a:rPr>
-              <a:t>같은 형태를 공유하지만, 차이는 색이 아니라 표면과 실루엣에서 먼저 드러납니다.</a:t>
+              <a:t>차이는 색이 아니라 표면과 실루엣에서 먼저 드러납니다.</a:t>
             </a:r>
             <a:endParaRPr lang="en-US" sz="900" dirty="0"/>
           </a:p>
@@ -7154,7 +7005,7 @@
                 <a:ea typeface="Noto Sans KR" pitchFamily="34" charset="-122"/>
                 <a:cs typeface="Noto Sans KR" pitchFamily="34" charset="-120"/>
               </a:rPr>
-              <a:t>아이보리 기가 남아 있는 부드러운 색감</a:t>
+              <a:t>아이보리 기가 남은 부드러운 색감</a:t>
             </a:r>
             <a:endParaRPr lang="en-US" sz="850" dirty="0"/>
           </a:p>
@@ -7410,7 +7261,7 @@
                 <a:ea typeface="Noto Sans KR" pitchFamily="34" charset="-122"/>
                 <a:cs typeface="Noto Sans KR" pitchFamily="34" charset="-120"/>
               </a:rPr>
-              <a:t>최소한으로 절제한 하이라이트</a:t>
+              <a:t>절제한 하이라이트</a:t>
             </a:r>
             <a:endParaRPr lang="en-US" sz="850" dirty="0"/>
           </a:p>
@@ -7538,7 +7389,7 @@
                 <a:ea typeface="Noto Sans KR" pitchFamily="34" charset="-122"/>
                 <a:cs typeface="Noto Sans KR" pitchFamily="34" charset="-120"/>
               </a:rPr>
-              <a:t>표면이 흔들리지 않는 정돈된 마감</a:t>
+              <a:t>흔들림 없는 정돈된 마감</a:t>
             </a:r>
             <a:endParaRPr lang="en-US" sz="850" dirty="0"/>
           </a:p>
@@ -7602,7 +7453,7 @@
                 <a:ea typeface="Noto Sans KR" pitchFamily="34" charset="-122"/>
                 <a:cs typeface="Noto Sans KR" pitchFamily="34" charset="-120"/>
               </a:rPr>
-              <a:t>사실적이지 않으면서 물성은 남는 표현</a:t>
+              <a:t>사실적이지 않아도 물성은 남는 표현</a:t>
             </a:r>
             <a:endParaRPr lang="en-US" sz="850" dirty="0"/>
           </a:p>
@@ -7795,7 +7646,7 @@
                 <a:ea typeface="Noto Sans KR" pitchFamily="34" charset="-122"/>
                 <a:cs typeface="Noto Sans KR" pitchFamily="34" charset="-120"/>
               </a:rPr>
-              <a:t>캐릭터의 수를 늘리는 방식이 아니라, 새로운 물질을 만날 때마다</a:t>
+              <a:t>캐릭터를 늘리는 게 아니라, 새로운 물질을 만날 때마다</a:t>
             </a:r>
             <a:endParaRPr lang="en-US" sz="1000" dirty="0"/>
           </a:p>
@@ -7815,7 +7666,7 @@
                 <a:ea typeface="Noto Sans KR" pitchFamily="34" charset="-122"/>
                 <a:cs typeface="Noto Sans KR" pitchFamily="34" charset="-120"/>
               </a:rPr>
-              <a:t>세계가 한 겹씩 넓어지는 구조입니다.</a:t>
+              <a:t>세계가 한 겹씩 넓어집니다.</a:t>
             </a:r>
             <a:endParaRPr lang="en-US" sz="1000" dirty="0"/>
           </a:p>
@@ -8519,7 +8370,7 @@
                 <a:ea typeface="Noto Sans KR" pitchFamily="34" charset="-122"/>
                 <a:cs typeface="Noto Sans KR" pitchFamily="34" charset="-120"/>
               </a:rPr>
-              <a:t>확정된 제품 계획이 아니라, 앞으로 탐구할 수 있는 물질의 방향입니다.</a:t>
+              <a:t>확정된 계획이 아니라, 앞으로 탐구할 수 있는 방향입니다.</a:t>
             </a:r>
             <a:endParaRPr lang="en-US" sz="900" dirty="0"/>
           </a:p>

</xml_diff>